<commit_message>
Missed a unit, NOW final poster
</commit_message>
<xml_diff>
--- a/poster.pptx
+++ b/poster.pptx
@@ -9971,7 +9971,7 @@
               <p:nvPr>
                 <p:extLst>
                   <p:ext uri="{D42A27DB-BD31-4B8C-83A1-F6EECF244321}">
-                    <p14:modId xmlns:p14="http://schemas.microsoft.com/office/powerpoint/2010/main" val="419790620"/>
+                    <p14:modId xmlns:p14="http://schemas.microsoft.com/office/powerpoint/2010/main" val="3932641516"/>
                   </p:ext>
                 </p:extLst>
               </p:nvPr>
@@ -10169,7 +10169,7 @@
                           <a:pPr algn="ctr"/>
                           <a:r>
                             <a:rPr lang="en-GB" sz="2200" dirty="0"/>
-                            <a:t>1.148s</a:t>
+                            <a:t>1.148 s</a:t>
                           </a:r>
                         </a:p>
                       </a:txBody>
@@ -10248,7 +10248,7 @@
                           <a:pPr algn="ctr"/>
                           <a:r>
                             <a:rPr lang="en-GB" sz="2200" dirty="0"/>
-                            <a:t>0.024s</a:t>
+                            <a:t>0.024 s</a:t>
                           </a:r>
                         </a:p>
                       </a:txBody>
@@ -10327,7 +10327,7 @@
                           <a:pPr algn="ctr"/>
                           <a:r>
                             <a:rPr lang="en-GB" sz="2200" dirty="0"/>
-                            <a:t>1.615s</a:t>
+                            <a:t>1.615 s</a:t>
                           </a:r>
                         </a:p>
                       </a:txBody>
@@ -10405,9 +10405,10 @@
                         <a:p>
                           <a:pPr algn="ctr"/>
                           <a:r>
-                            <a:rPr lang="en-GB" sz="2200" dirty="0"/>
-                            <a:t>0.189s</a:t>
+                            <a:rPr lang="en-GB" sz="2200"/>
+                            <a:t>0.189 s</a:t>
                           </a:r>
+                          <a:endParaRPr lang="en-GB" sz="2200" dirty="0"/>
                         </a:p>
                       </a:txBody>
                       <a:tcPr anchor="ctr"/>
@@ -10439,7 +10440,7 @@
               <p:nvPr>
                 <p:extLst>
                   <p:ext uri="{D42A27DB-BD31-4B8C-83A1-F6EECF244321}">
-                    <p14:modId xmlns:p14="http://schemas.microsoft.com/office/powerpoint/2010/main" val="419790620"/>
+                    <p14:modId xmlns:p14="http://schemas.microsoft.com/office/powerpoint/2010/main" val="3932641516"/>
                   </p:ext>
                 </p:extLst>
               </p:nvPr>
@@ -10617,7 +10618,7 @@
                           <a:pPr algn="ctr"/>
                           <a:r>
                             <a:rPr lang="en-GB" sz="2200" dirty="0"/>
-                            <a:t>1.148s</a:t>
+                            <a:t>1.148 s</a:t>
                           </a:r>
                         </a:p>
                       </a:txBody>
@@ -10696,7 +10697,7 @@
                           <a:pPr algn="ctr"/>
                           <a:r>
                             <a:rPr lang="en-GB" sz="2200" dirty="0"/>
-                            <a:t>0.024s</a:t>
+                            <a:t>0.024 s</a:t>
                           </a:r>
                         </a:p>
                       </a:txBody>
@@ -10775,7 +10776,7 @@
                           <a:pPr algn="ctr"/>
                           <a:r>
                             <a:rPr lang="en-GB" sz="2200" dirty="0"/>
-                            <a:t>1.615s</a:t>
+                            <a:t>1.615 s</a:t>
                           </a:r>
                         </a:p>
                       </a:txBody>
@@ -10853,9 +10854,10 @@
                         <a:p>
                           <a:pPr algn="ctr"/>
                           <a:r>
-                            <a:rPr lang="en-GB" sz="2200" dirty="0"/>
-                            <a:t>0.189s</a:t>
+                            <a:rPr lang="en-GB" sz="2200"/>
+                            <a:t>0.189 s</a:t>
                           </a:r>
+                          <a:endParaRPr lang="en-GB" sz="2200" dirty="0"/>
                         </a:p>
                       </a:txBody>
                       <a:tcPr anchor="ctr"/>

</xml_diff>